<commit_message>
test(final): validate end-to-end workflow and presentation evidence
</commit_message>
<xml_diff>
--- a/docs/presentation/final-project-presentation.pptx
+++ b/docs/presentation/final-project-presentation.pptx
@@ -5454,8 +5454,8 @@
         </p:nvSpPr>
         <p:spPr>
           <a:xfrm>
-            <a:off x="731520" y="1371600"/>
-            <a:ext cx="5120640" cy="2286000"/>
+            <a:off x="731520" y="1280160"/>
+            <a:ext cx="5120640" cy="2423160"/>
           </a:xfrm>
           <a:prstGeom prst="roundRect">
             <a:avLst/>
@@ -5499,7 +5499,7 @@
         </p:nvSpPr>
         <p:spPr>
           <a:xfrm>
-            <a:off x="914400" y="1508760"/>
+            <a:off x="914400" y="1417319"/>
             <a:ext cx="4754879" cy="365760"/>
           </a:xfrm>
           <a:prstGeom prst="rect">
@@ -5527,105 +5527,40 @@
           </a:p>
         </p:txBody>
       </p:sp>
-      <p:sp>
-        <p:nvSpPr>
-          <p:cNvPr id="5" name="Rectangle 4"/>
+      <p:pic>
+        <p:nvPicPr>
+          <p:cNvPr id="5" name="Picture 4" descr="01_citizen_submission.png"/>
+          <p:cNvPicPr>
+            <a:picLocks noChangeAspect="1"/>
+          </p:cNvPicPr>
+          <p:nvPr/>
+        </p:nvPicPr>
+        <p:blipFill>
+          <a:blip r:embed="rId2"/>
+          <a:stretch>
+            <a:fillRect/>
+          </a:stretch>
+        </p:blipFill>
+        <p:spPr>
+          <a:xfrm>
+            <a:off x="868680" y="1737360"/>
+            <a:ext cx="4846320" cy="1828800"/>
+          </a:xfrm>
+          <a:prstGeom prst="rect">
+            <a:avLst/>
+          </a:prstGeom>
+        </p:spPr>
+      </p:pic>
+      <p:sp>
+        <p:nvSpPr>
+          <p:cNvPr id="6" name="Rounded Rectangle 5"/>
           <p:cNvSpPr/>
           <p:nvPr/>
         </p:nvSpPr>
         <p:spPr>
           <a:xfrm>
-            <a:off x="914400" y="1828800"/>
-            <a:ext cx="4754880" cy="1097280"/>
-          </a:xfrm>
-          <a:prstGeom prst="rect">
-            <a:avLst/>
-          </a:prstGeom>
-          <a:solidFill>
-            <a:srgbClr val="F1F5F9"/>
-          </a:solidFill>
-          <a:ln>
-            <a:solidFill>
-              <a:srgbClr val="E2E8F0"/>
-            </a:solidFill>
-          </a:ln>
-        </p:spPr>
-        <p:style>
-          <a:lnRef idx="1">
-            <a:schemeClr val="accent1"/>
-          </a:lnRef>
-          <a:fillRef idx="3">
-            <a:schemeClr val="accent1"/>
-          </a:fillRef>
-          <a:effectRef idx="2">
-            <a:schemeClr val="accent1"/>
-          </a:effectRef>
-          <a:fontRef idx="minor">
-            <a:schemeClr val="lt1"/>
-          </a:fontRef>
-        </p:style>
-        <p:txBody>
-          <a:bodyPr rtlCol="0" anchor="ctr"/>
-          <a:lstStyle/>
-          <a:p>
-            <a:pPr algn="ctr">
-              <a:defRPr sz="1100" b="1">
-                <a:solidFill>
-                  <a:srgbClr val="1D4ED8"/>
-                </a:solidFill>
-              </a:defRPr>
-            </a:pPr>
-            <a:r>
-              <a:t>[ Screen Showcase Placeholder: 1. Citizen Submission ]</a:t>
-            </a:r>
-          </a:p>
-        </p:txBody>
-      </p:sp>
-      <p:sp>
-        <p:nvSpPr>
-          <p:cNvPr id="6" name="TextBox 5"/>
-          <p:cNvSpPr txBox="1"/>
-          <p:nvPr/>
-        </p:nvSpPr>
-        <p:spPr>
-          <a:xfrm>
-            <a:off x="914400" y="3017520"/>
-            <a:ext cx="4754880" cy="548640"/>
-          </a:xfrm>
-          <a:prstGeom prst="rect">
-            <a:avLst/>
-          </a:prstGeom>
-          <a:noFill/>
-        </p:spPr>
-        <p:txBody>
-          <a:bodyPr wrap="square">
-            <a:spAutoFit/>
-          </a:bodyPr>
-          <a:lstStyle/>
-          <a:p>
-            <a:pPr>
-              <a:defRPr sz="1000">
-                <a:solidFill>
-                  <a:srgbClr val="1E293B"/>
-                </a:solidFill>
-              </a:defRPr>
-            </a:pPr>
-            <a:r>
-              <a:t>Interactive form with AI prediction badge, confidence score, priority level, and XAI terms.</a:t>
-            </a:r>
-          </a:p>
-        </p:txBody>
-      </p:sp>
-      <p:sp>
-        <p:nvSpPr>
-          <p:cNvPr id="7" name="Rounded Rectangle 6"/>
-          <p:cNvSpPr/>
-          <p:nvPr/>
-        </p:nvSpPr>
-        <p:spPr>
-          <a:xfrm>
-            <a:off x="6126480" y="1371600"/>
-            <a:ext cx="5120640" cy="2286000"/>
+            <a:off x="6126480" y="1280160"/>
+            <a:ext cx="5120640" cy="2423160"/>
           </a:xfrm>
           <a:prstGeom prst="roundRect">
             <a:avLst/>
@@ -5663,13 +5598,13 @@
       </p:sp>
       <p:sp>
         <p:nvSpPr>
-          <p:cNvPr id="8" name="TextBox 7"/>
+          <p:cNvPr id="7" name="TextBox 6"/>
           <p:cNvSpPr txBox="1"/>
           <p:nvPr/>
         </p:nvSpPr>
         <p:spPr>
           <a:xfrm>
-            <a:off x="6309360" y="1508760"/>
+            <a:off x="6309360" y="1417319"/>
             <a:ext cx="4754879" cy="365760"/>
           </a:xfrm>
           <a:prstGeom prst="rect">
@@ -5692,110 +5627,45 @@
               </a:defRPr>
             </a:pPr>
             <a:r>
-              <a:t>2. Chatbot Interface</a:t>
-            </a:r>
-          </a:p>
-        </p:txBody>
-      </p:sp>
-      <p:sp>
-        <p:nvSpPr>
-          <p:cNvPr id="9" name="Rectangle 8"/>
+              <a:t>2. Multilingual Chatbot</a:t>
+            </a:r>
+          </a:p>
+        </p:txBody>
+      </p:sp>
+      <p:pic>
+        <p:nvPicPr>
+          <p:cNvPr id="8" name="Picture 7" descr="02_chatbot_interaction.png"/>
+          <p:cNvPicPr>
+            <a:picLocks noChangeAspect="1"/>
+          </p:cNvPicPr>
+          <p:nvPr/>
+        </p:nvPicPr>
+        <p:blipFill>
+          <a:blip r:embed="rId3"/>
+          <a:stretch>
+            <a:fillRect/>
+          </a:stretch>
+        </p:blipFill>
+        <p:spPr>
+          <a:xfrm>
+            <a:off x="6263640" y="1737360"/>
+            <a:ext cx="4846320" cy="1828800"/>
+          </a:xfrm>
+          <a:prstGeom prst="rect">
+            <a:avLst/>
+          </a:prstGeom>
+        </p:spPr>
+      </p:pic>
+      <p:sp>
+        <p:nvSpPr>
+          <p:cNvPr id="9" name="Rounded Rectangle 8"/>
           <p:cNvSpPr/>
           <p:nvPr/>
         </p:nvSpPr>
         <p:spPr>
           <a:xfrm>
-            <a:off x="6309360" y="1828800"/>
-            <a:ext cx="4754880" cy="1097280"/>
-          </a:xfrm>
-          <a:prstGeom prst="rect">
-            <a:avLst/>
-          </a:prstGeom>
-          <a:solidFill>
-            <a:srgbClr val="F1F5F9"/>
-          </a:solidFill>
-          <a:ln>
-            <a:solidFill>
-              <a:srgbClr val="E2E8F0"/>
-            </a:solidFill>
-          </a:ln>
-        </p:spPr>
-        <p:style>
-          <a:lnRef idx="1">
-            <a:schemeClr val="accent1"/>
-          </a:lnRef>
-          <a:fillRef idx="3">
-            <a:schemeClr val="accent1"/>
-          </a:fillRef>
-          <a:effectRef idx="2">
-            <a:schemeClr val="accent1"/>
-          </a:effectRef>
-          <a:fontRef idx="minor">
-            <a:schemeClr val="lt1"/>
-          </a:fontRef>
-        </p:style>
-        <p:txBody>
-          <a:bodyPr rtlCol="0" anchor="ctr"/>
-          <a:lstStyle/>
-          <a:p>
-            <a:pPr algn="ctr">
-              <a:defRPr sz="1100" b="1">
-                <a:solidFill>
-                  <a:srgbClr val="1D4ED8"/>
-                </a:solidFill>
-              </a:defRPr>
-            </a:pPr>
-            <a:r>
-              <a:t>[ Screen Showcase Placeholder: 2. Chatbot Interface ]</a:t>
-            </a:r>
-          </a:p>
-        </p:txBody>
-      </p:sp>
-      <p:sp>
-        <p:nvSpPr>
-          <p:cNvPr id="10" name="TextBox 9"/>
-          <p:cNvSpPr txBox="1"/>
-          <p:nvPr/>
-        </p:nvSpPr>
-        <p:spPr>
-          <a:xfrm>
-            <a:off x="6309360" y="3017520"/>
-            <a:ext cx="4754880" cy="548640"/>
-          </a:xfrm>
-          <a:prstGeom prst="rect">
-            <a:avLst/>
-          </a:prstGeom>
-          <a:noFill/>
-        </p:spPr>
-        <p:txBody>
-          <a:bodyPr wrap="square">
-            <a:spAutoFit/>
-          </a:bodyPr>
-          <a:lstStyle/>
-          <a:p>
-            <a:pPr>
-              <a:defRPr sz="1000">
-                <a:solidFill>
-                  <a:srgbClr val="1E293B"/>
-                </a:solidFill>
-              </a:defRPr>
-            </a:pPr>
-            <a:r>
-              <a:t>Multi-turn assistant extracting GRV reference codes and displaying live status cards.</a:t>
-            </a:r>
-          </a:p>
-        </p:txBody>
-      </p:sp>
-      <p:sp>
-        <p:nvSpPr>
-          <p:cNvPr id="11" name="Rounded Rectangle 10"/>
-          <p:cNvSpPr/>
-          <p:nvPr/>
-        </p:nvSpPr>
-        <p:spPr>
-          <a:xfrm>
-            <a:off x="731520" y="3840480"/>
-            <a:ext cx="5120640" cy="2286000"/>
+            <a:off x="731520" y="3840479"/>
+            <a:ext cx="5120640" cy="2423160"/>
           </a:xfrm>
           <a:prstGeom prst="roundRect">
             <a:avLst/>
@@ -5833,13 +5703,13 @@
       </p:sp>
       <p:sp>
         <p:nvSpPr>
-          <p:cNvPr id="12" name="TextBox 11"/>
+          <p:cNvPr id="10" name="TextBox 9"/>
           <p:cNvSpPr txBox="1"/>
           <p:nvPr/>
         </p:nvSpPr>
         <p:spPr>
           <a:xfrm>
-            <a:off x="914400" y="3977640"/>
+            <a:off x="914400" y="3977639"/>
             <a:ext cx="4754879" cy="365760"/>
           </a:xfrm>
           <a:prstGeom prst="rect">
@@ -5867,105 +5737,40 @@
           </a:p>
         </p:txBody>
       </p:sp>
-      <p:sp>
-        <p:nvSpPr>
-          <p:cNvPr id="13" name="Rectangle 12"/>
+      <p:pic>
+        <p:nvPicPr>
+          <p:cNvPr id="11" name="Picture 10" descr="03_officer_queue.png"/>
+          <p:cNvPicPr>
+            <a:picLocks noChangeAspect="1"/>
+          </p:cNvPicPr>
+          <p:nvPr/>
+        </p:nvPicPr>
+        <p:blipFill>
+          <a:blip r:embed="rId4"/>
+          <a:stretch>
+            <a:fillRect/>
+          </a:stretch>
+        </p:blipFill>
+        <p:spPr>
+          <a:xfrm>
+            <a:off x="868680" y="4297679"/>
+            <a:ext cx="4846320" cy="1828800"/>
+          </a:xfrm>
+          <a:prstGeom prst="rect">
+            <a:avLst/>
+          </a:prstGeom>
+        </p:spPr>
+      </p:pic>
+      <p:sp>
+        <p:nvSpPr>
+          <p:cNvPr id="12" name="Rounded Rectangle 11"/>
           <p:cNvSpPr/>
           <p:nvPr/>
         </p:nvSpPr>
         <p:spPr>
           <a:xfrm>
-            <a:off x="914400" y="4297680"/>
-            <a:ext cx="4754880" cy="1097280"/>
-          </a:xfrm>
-          <a:prstGeom prst="rect">
-            <a:avLst/>
-          </a:prstGeom>
-          <a:solidFill>
-            <a:srgbClr val="F1F5F9"/>
-          </a:solidFill>
-          <a:ln>
-            <a:solidFill>
-              <a:srgbClr val="E2E8F0"/>
-            </a:solidFill>
-          </a:ln>
-        </p:spPr>
-        <p:style>
-          <a:lnRef idx="1">
-            <a:schemeClr val="accent1"/>
-          </a:lnRef>
-          <a:fillRef idx="3">
-            <a:schemeClr val="accent1"/>
-          </a:fillRef>
-          <a:effectRef idx="2">
-            <a:schemeClr val="accent1"/>
-          </a:effectRef>
-          <a:fontRef idx="minor">
-            <a:schemeClr val="lt1"/>
-          </a:fontRef>
-        </p:style>
-        <p:txBody>
-          <a:bodyPr rtlCol="0" anchor="ctr"/>
-          <a:lstStyle/>
-          <a:p>
-            <a:pPr algn="ctr">
-              <a:defRPr sz="1100" b="1">
-                <a:solidFill>
-                  <a:srgbClr val="1D4ED8"/>
-                </a:solidFill>
-              </a:defRPr>
-            </a:pPr>
-            <a:r>
-              <a:t>[ Screen Showcase Placeholder: 3. Officer Queue ]</a:t>
-            </a:r>
-          </a:p>
-        </p:txBody>
-      </p:sp>
-      <p:sp>
-        <p:nvSpPr>
-          <p:cNvPr id="14" name="TextBox 13"/>
-          <p:cNvSpPr txBox="1"/>
-          <p:nvPr/>
-        </p:nvSpPr>
-        <p:spPr>
-          <a:xfrm>
-            <a:off x="914400" y="5486400"/>
-            <a:ext cx="4754880" cy="548640"/>
-          </a:xfrm>
-          <a:prstGeom prst="rect">
-            <a:avLst/>
-          </a:prstGeom>
-          <a:noFill/>
-        </p:spPr>
-        <p:txBody>
-          <a:bodyPr wrap="square">
-            <a:spAutoFit/>
-          </a:bodyPr>
-          <a:lstStyle/>
-          <a:p>
-            <a:pPr>
-              <a:defRPr sz="1000">
-                <a:solidFill>
-                  <a:srgbClr val="1E293B"/>
-                </a:solidFill>
-              </a:defRPr>
-            </a:pPr>
-            <a:r>
-              <a:t>Department-locked queue (e.g. Water Supply) enforcing mandatory remarks on status updates.</a:t>
-            </a:r>
-          </a:p>
-        </p:txBody>
-      </p:sp>
-      <p:sp>
-        <p:nvSpPr>
-          <p:cNvPr id="15" name="Rounded Rectangle 14"/>
-          <p:cNvSpPr/>
-          <p:nvPr/>
-        </p:nvSpPr>
-        <p:spPr>
-          <a:xfrm>
-            <a:off x="6126480" y="3840480"/>
-            <a:ext cx="5120640" cy="2286000"/>
+            <a:off x="6126480" y="3840479"/>
+            <a:ext cx="5120640" cy="2423160"/>
           </a:xfrm>
           <a:prstGeom prst="roundRect">
             <a:avLst/>
@@ -6003,13 +5808,13 @@
       </p:sp>
       <p:sp>
         <p:nvSpPr>
-          <p:cNvPr id="16" name="TextBox 15"/>
+          <p:cNvPr id="13" name="TextBox 12"/>
           <p:cNvSpPr txBox="1"/>
           <p:nvPr/>
         </p:nvSpPr>
         <p:spPr>
           <a:xfrm>
-            <a:off x="6309360" y="3977640"/>
+            <a:off x="6309360" y="3977639"/>
             <a:ext cx="4754879" cy="365760"/>
           </a:xfrm>
           <a:prstGeom prst="rect">
@@ -6037,95 +5842,30 @@
           </a:p>
         </p:txBody>
       </p:sp>
-      <p:sp>
-        <p:nvSpPr>
-          <p:cNvPr id="17" name="Rectangle 16"/>
-          <p:cNvSpPr/>
-          <p:nvPr/>
-        </p:nvSpPr>
-        <p:spPr>
-          <a:xfrm>
-            <a:off x="6309360" y="4297680"/>
-            <a:ext cx="4754880" cy="1097280"/>
+      <p:pic>
+        <p:nvPicPr>
+          <p:cNvPr id="14" name="Picture 13" descr="04_admin_dashboard.png"/>
+          <p:cNvPicPr>
+            <a:picLocks noChangeAspect="1"/>
+          </p:cNvPicPr>
+          <p:nvPr/>
+        </p:nvPicPr>
+        <p:blipFill>
+          <a:blip r:embed="rId5"/>
+          <a:stretch>
+            <a:fillRect/>
+          </a:stretch>
+        </p:blipFill>
+        <p:spPr>
+          <a:xfrm>
+            <a:off x="6263640" y="4297679"/>
+            <a:ext cx="4846320" cy="1828800"/>
           </a:xfrm>
           <a:prstGeom prst="rect">
             <a:avLst/>
           </a:prstGeom>
-          <a:solidFill>
-            <a:srgbClr val="F1F5F9"/>
-          </a:solidFill>
-          <a:ln>
-            <a:solidFill>
-              <a:srgbClr val="E2E8F0"/>
-            </a:solidFill>
-          </a:ln>
-        </p:spPr>
-        <p:style>
-          <a:lnRef idx="1">
-            <a:schemeClr val="accent1"/>
-          </a:lnRef>
-          <a:fillRef idx="3">
-            <a:schemeClr val="accent1"/>
-          </a:fillRef>
-          <a:effectRef idx="2">
-            <a:schemeClr val="accent1"/>
-          </a:effectRef>
-          <a:fontRef idx="minor">
-            <a:schemeClr val="lt1"/>
-          </a:fontRef>
-        </p:style>
-        <p:txBody>
-          <a:bodyPr rtlCol="0" anchor="ctr"/>
-          <a:lstStyle/>
-          <a:p>
-            <a:pPr algn="ctr">
-              <a:defRPr sz="1100" b="1">
-                <a:solidFill>
-                  <a:srgbClr val="1D4ED8"/>
-                </a:solidFill>
-              </a:defRPr>
-            </a:pPr>
-            <a:r>
-              <a:t>[ Screen Showcase Placeholder: 4. Admin Overview ]</a:t>
-            </a:r>
-          </a:p>
-        </p:txBody>
-      </p:sp>
-      <p:sp>
-        <p:nvSpPr>
-          <p:cNvPr id="18" name="TextBox 17"/>
-          <p:cNvSpPr txBox="1"/>
-          <p:nvPr/>
-        </p:nvSpPr>
-        <p:spPr>
-          <a:xfrm>
-            <a:off x="6309360" y="5486400"/>
-            <a:ext cx="4754880" cy="548640"/>
-          </a:xfrm>
-          <a:prstGeom prst="rect">
-            <a:avLst/>
-          </a:prstGeom>
-          <a:noFill/>
-        </p:spPr>
-        <p:txBody>
-          <a:bodyPr wrap="square">
-            <a:spAutoFit/>
-          </a:bodyPr>
-          <a:lstStyle/>
-          <a:p>
-            <a:pPr>
-              <a:defRPr sz="1000">
-                <a:solidFill>
-                  <a:srgbClr val="1E293B"/>
-                </a:solidFill>
-              </a:defRPr>
-            </a:pPr>
-            <a:r>
-              <a:t>System-wide analytics, low-confidence review flags, and human classification correction modal.</a:t>
-            </a:r>
-          </a:p>
-        </p:txBody>
-      </p:sp>
+        </p:spPr>
+      </p:pic>
     </p:spTree>
   </p:cSld>
   <p:clrMapOvr>
@@ -7461,7 +7201,7 @@
                   <a:srgbClr val="1E293B"/>
                 </a:solidFill>
               </a:rPr>
-              <a:t>Citizens select wrong departments in manual forms, causing multi-week inter-department transfers.</a:t>
+              <a:t>Citizens manually select target departments from dropdown menus, leading to inter-department transfers.</a:t>
             </a:r>
           </a:p>
           <a:p>
@@ -7657,7 +7397,7 @@
                   <a:srgbClr val="1E293B"/>
                 </a:solidFill>
               </a:rPr>
-              <a:t>Manual sorting takes 3-7 days per complaint before reaching the assigned officer queue.</a:t>
+              <a:t>Manual sorting creates processing delays before complaints reach officer queues.</a:t>
             </a:r>
           </a:p>
           <a:p>
@@ -7680,7 +7420,7 @@
                   <a:srgbClr val="1E293B"/>
                 </a:solidFill>
               </a:rPr>
-              <a:t>Up to 25-30% of citizen-selected departments are incorrect in manual forms.</a:t>
+              <a:t>High frequency of inter-department misrouting when citizens select target departments manually.</a:t>
             </a:r>
           </a:p>
           <a:p>
@@ -7703,7 +7443,7 @@
                   <a:srgbClr val="1E293B"/>
                 </a:solidFill>
               </a:rPr>
-              <a:t>No automated keyword detection to escalate urgent leaks, power hazards, or contamination.</a:t>
+              <a:t>Lack of automated keyword detection to escalate urgent leaks, power hazards, or contamination.</a:t>
             </a:r>
           </a:p>
           <a:p>
@@ -7726,7 +7466,7 @@
                   <a:srgbClr val="1E293B"/>
                 </a:solidFill>
               </a:rPr>
-              <a:t>Non-English regional complaints face severe delays due to manual script identification.</a:t>
+              <a:t>Non-English regional complaints face severe processing delays due to manual script identification.</a:t>
             </a:r>
           </a:p>
         </p:txBody>

</xml_diff>

<commit_message>
docs(final): reconcile evaluation metrics and presentation
</commit_message>
<xml_diff>
--- a/docs/presentation/final-project-presentation.pptx
+++ b/docs/presentation/final-project-presentation.pptx
@@ -6388,7 +6388,7 @@
               </a:defRPr>
             </a:pPr>
             <a:r>
-              <a:t>Academic Synthetic Dataset Evaluation Summary</a:t>
+              <a:t>Empirical ML Evaluation: Clean Benchmark vs Realistic Edge Cases</a:t>
             </a:r>
           </a:p>
         </p:txBody>
@@ -6417,93 +6417,116 @@
           <a:p>
             <a:pPr>
               <a:spcAft>
-                <a:spcPts val="600"/>
+                <a:spcPts val="400"/>
               </a:spcAft>
-              <a:defRPr b="1" sz="1100">
+              <a:defRPr b="1" sz="1050">
                 <a:solidFill>
                   <a:srgbClr val="1D4ED8"/>
                 </a:solidFill>
               </a:defRPr>
             </a:pPr>
             <a:r>
-              <a:t>• Dataset Composition: </a:t>
-            </a:r>
-            <a:r>
-              <a:rPr b="0" sz="1100">
+              <a:t>• Clean Benchmark Split: </a:t>
+            </a:r>
+            <a:r>
+              <a:rPr b="0" sz="1050">
                 <a:solidFill>
                   <a:srgbClr val="1E293B"/>
                 </a:solidFill>
               </a:rPr>
-              <a:t>675 academic synthetic samples split into Train (472, 70%), Validation (101, 15%), and Test (102, 15%). Seed: 42.</a:t>
+              <a:t>675 synthetic samples split strictly into Train (472, 70%), Validation (101, 15%), and Test (102, 15%). Seed: 42.</a:t>
             </a:r>
           </a:p>
           <a:p>
             <a:pPr>
               <a:spcAft>
-                <a:spcPts val="600"/>
+                <a:spcPts val="400"/>
               </a:spcAft>
-              <a:defRPr b="1" sz="1100">
+              <a:defRPr b="1" sz="1050">
                 <a:solidFill>
                   <a:srgbClr val="1D4ED8"/>
                 </a:solidFill>
               </a:defRPr>
             </a:pPr>
             <a:r>
-              <a:t>• Validation Accuracy: </a:t>
-            </a:r>
-            <a:r>
-              <a:rPr b="0" sz="1100">
+              <a:t>• Clean Test Accuracy: </a:t>
+            </a:r>
+            <a:r>
+              <a:rPr b="0" sz="1050">
                 <a:solidFill>
                   <a:srgbClr val="1E293B"/>
                 </a:solidFill>
               </a:rPr>
-              <a:t>100.0% accuracy, precision, recall, and F1-score on the clean synthetic validation split (validation.csv).</a:t>
+              <a:t>100.0% accuracy, precision, recall, and F1-score on clean held-out test split (102 samples) via evaluate_classifier.py.</a:t>
             </a:r>
           </a:p>
           <a:p>
             <a:pPr>
               <a:spcAft>
-                <a:spcPts val="600"/>
+                <a:spcPts val="400"/>
               </a:spcAft>
-              <a:defRPr b="1" sz="1100">
+              <a:defRPr b="1" sz="1050">
                 <a:solidFill>
                   <a:srgbClr val="1D4ED8"/>
                 </a:solidFill>
               </a:defRPr>
             </a:pPr>
             <a:r>
+              <a:t>• Realistic Edge-Case Test: </a:t>
+            </a:r>
+            <a:r>
+              <a:rPr b="0" sz="1050">
+                <a:solidFill>
+                  <a:srgbClr val="1E293B"/>
+                </a:solidFill>
+              </a:rPr>
+              <a:t>79.63% accuracy (86/108 correct) on 108 realistic validation cases with typos, slang, and multi-issue text via error_analysis.py.</a:t>
+            </a:r>
+          </a:p>
+          <a:p>
+            <a:pPr>
+              <a:spcAft>
+                <a:spcPts val="400"/>
+              </a:spcAft>
+              <a:defRPr b="1" sz="1050">
+                <a:solidFill>
+                  <a:srgbClr val="1D4ED8"/>
+                </a:solidFill>
+              </a:defRPr>
+            </a:pPr>
+            <a:r>
+              <a:t>• Human Review Safety Net: </a:t>
+            </a:r>
+            <a:r>
+              <a:rPr b="0" sz="1050">
+                <a:solidFill>
+                  <a:srgbClr val="1E293B"/>
+                </a:solidFill>
+              </a:rPr>
+              <a:t>88.9% (96/108) of ambiguous validation cases safely flagged for Human Review (confidence &lt; 0.75), preventing automated misrouting.</a:t>
+            </a:r>
+          </a:p>
+          <a:p>
+            <a:pPr>
+              <a:spcAft>
+                <a:spcPts val="400"/>
+              </a:spcAft>
+              <a:defRPr b="1" sz="1050">
+                <a:solidFill>
+                  <a:srgbClr val="1D4ED8"/>
+                </a:solidFill>
+              </a:defRPr>
+            </a:pPr>
+            <a:r>
               <a:t>• Academic Honesty: </a:t>
             </a:r>
             <a:r>
-              <a:rPr b="0" sz="1100">
+              <a:rPr b="0" sz="1050">
                 <a:solidFill>
                   <a:srgbClr val="1E293B"/>
                 </a:solidFill>
               </a:rPr>
-              <a:t>Synthetic dataset performance does NOT equal real-world portal accuracy. Real citizen complaints contain heavy noise and spelling typos.</a:t>
-            </a:r>
-          </a:p>
-          <a:p>
-            <a:pPr>
-              <a:spcAft>
-                <a:spcPts val="600"/>
-              </a:spcAft>
-              <a:defRPr b="1" sz="1100">
-                <a:solidFill>
-                  <a:srgbClr val="1D4ED8"/>
-                </a:solidFill>
-              </a:defRPr>
-            </a:pPr>
-            <a:r>
-              <a:t>• Docker Compose Config: </a:t>
-            </a:r>
-            <a:r>
-              <a:rPr b="0" sz="1100">
-                <a:solidFill>
-                  <a:srgbClr val="1E293B"/>
-                </a:solidFill>
-              </a:rPr>
-              <a:t>docker compose config validated syntax across all 4 containerized microservices.</a:t>
+              <a:t>Synthetic templates achieve 100%, but noisy inputs reduce direct ML accuracy to ~80%, proving the necessity of confidence thresholding.</a:t>
             </a:r>
           </a:p>
         </p:txBody>

</xml_diff>